<commit_message>
Régénère les diagrammes drawio et met à jour la présentation
- Architecture, ERD, MongoDB et structure du code régénérés depuis le code :
  write-back fraud_indicators, RGPD, requêtes, Terraform, sans chevauchements
- Images remplacées dans la présentation et les deux documents Word
- Identifiants de démo du dashboard dans la présentation, le README,
  la documentation et le script vidéo
</commit_message>
<xml_diff>
--- a/presentation/stripe_presentation_bloc2.pptx
+++ b/presentation/stripe_presentation_bloc2.pptx
@@ -2764,7 +2764,7 @@
                 <a:ea typeface="Calibri" pitchFamily="34" charset="-122"/>
                 <a:cs typeface="Calibri" pitchFamily="34" charset="-120"/>
               </a:rPr>
-              <a:t>Machine personnelle · Docker Compose</a:t>
+              <a:t>Docker Compose · localhost:8501 · admin / Bloc2-Demo-2026</a:t>
             </a:r>
             <a:endParaRPr lang="en-US" sz="1200" dirty="0"/>
           </a:p>
@@ -3748,8 +3748,8 @@
         </p:blipFill>
         <p:spPr>
           <a:xfrm>
-            <a:off x="380000" y="851780"/>
-            <a:ext cx="11432000" cy="5154439"/>
+            <a:off x="802619" y="380000"/>
+            <a:ext cx="10586761" cy="6098000"/>
           </a:xfrm>
           <a:prstGeom prst="rect">
             <a:avLst/>
@@ -3842,8 +3842,8 @@
         </p:blipFill>
         <p:spPr>
           <a:xfrm>
-            <a:off x="461353" y="380000"/>
-            <a:ext cx="11269293" cy="6098000"/>
+            <a:off x="828552" y="380000"/>
+            <a:ext cx="10534896" cy="6098000"/>
           </a:xfrm>
           <a:prstGeom prst="rect">
             <a:avLst/>
@@ -5701,8 +5701,8 @@
         </p:blipFill>
         <p:spPr>
           <a:xfrm>
-            <a:off x="1597883" y="380000"/>
-            <a:ext cx="8996233" cy="6098000"/>
+            <a:off x="1620920" y="380000"/>
+            <a:ext cx="8950160" cy="6098000"/>
           </a:xfrm>
           <a:prstGeom prst="rect">
             <a:avLst/>
@@ -8175,8 +8175,8 @@
         </p:blipFill>
         <p:spPr>
           <a:xfrm>
-            <a:off x="380000" y="669312"/>
-            <a:ext cx="11432000" cy="5519376"/>
+            <a:off x="1515802" y="380000"/>
+            <a:ext cx="9160396" cy="6098000"/>
           </a:xfrm>
           <a:prstGeom prst="rect">
             <a:avLst/>

</xml_diff>

<commit_message>
Complète les documents Word et la présentation avec tout le périmètre livré
- Architecture : section 5.6 sur le dashboard (connexion de démo, onglets
  Vue d'ensemble et Performance ML), job lint détaillé, figure 5 structure du code
- Compétences : incident du login Docker, requêtes et dashboard dans la
  documentation, figure de structure du code, identifiants de démo (C7)
- Présentation : nouvelle slide « Qualité, données et restitution »
  (tests 16/16, requêtes, RGPD, fraud_indicators, dashboard et MLOps)
</commit_message>
<xml_diff>
--- a/presentation/stripe_presentation_bloc2.pptx
+++ b/presentation/stripe_presentation_bloc2.pptx
@@ -20,6 +20,7 @@
     <p:sldId id="274" r:id="rId19"/>
     <p:sldId id="263" r:id="rId11"/>
     <p:sldId id="271" r:id="rId12"/>
+    <p:sldId id="277" r:id="rId22"/>
     <p:sldId id="276" r:id="rId21"/>
     <p:sldId id="265" r:id="rId13"/>
     <p:sldId id="275" r:id="rId20"/>
@@ -3945,6 +3946,748 @@
         </p:spPr>
       </p:pic>
     </p:spTree>
+  </p:cSld>
+  <p:clrMapOvr>
+    <a:masterClrMapping/>
+  </p:clrMapOvr>
+</p:sld>
+</file>
+
+<file path=ppt/slides/slide16.xml><?xml version="1.0" encoding="utf-8"?>
+<p:sld xmlns:a="http://schemas.openxmlformats.org/drawingml/2006/main" xmlns:r="http://schemas.openxmlformats.org/officeDocument/2006/relationships" xmlns:p="http://schemas.openxmlformats.org/presentationml/2006/main">
+  <p:cSld name="Slide 9">
+    <p:bg>
+      <p:bgPr>
+        <a:solidFill>
+          <a:srgbClr val="F4F5FB"/>
+        </a:solidFill>
+        <a:effectLst/>
+      </p:bgPr>
+    </p:bg>
+    <p:spTree>
+      <p:nvGrpSpPr>
+        <p:cNvPr id="1" name=""/>
+        <p:cNvGrpSpPr/>
+        <p:nvPr/>
+      </p:nvGrpSpPr>
+      <p:grpSpPr>
+        <a:xfrm>
+          <a:off x="0" y="0"/>
+          <a:ext cx="0" cy="0"/>
+          <a:chOff x="0" y="0"/>
+          <a:chExt cx="0" cy="0"/>
+        </a:xfrm>
+      </p:grpSpPr>
+      <p:sp>
+        <p:nvSpPr>
+          <p:cNvPr id="2" name="Text 0"/>
+          <p:cNvSpPr/>
+          <p:nvPr/>
+        </p:nvSpPr>
+        <p:spPr>
+          <a:xfrm>
+            <a:off x="548640" y="330200"/>
+            <a:ext cx="10972800" cy="274320"/>
+          </a:xfrm>
+          <a:prstGeom prst="rect">
+            <a:avLst/>
+          </a:prstGeom>
+          <a:noFill/>
+          <a:ln/>
+        </p:spPr>
+        <p:txBody>
+          <a:bodyPr wrap="square" lIns="0" tIns="0" rIns="0" bIns="0" rtlCol="0" anchor="ctr"/>
+          <a:lstStyle/>
+          <a:p>
+            <a:pPr marL="0" indent="0">
+              <a:buNone/>
+            </a:pPr>
+            <a:r>
+              <a:rPr lang="en-US" sz="1200" b="1" kern="0" spc="300" dirty="0">
+                <a:solidFill>
+                  <a:srgbClr val="6C63FF"/>
+                </a:solidFill>
+                <a:latin typeface="Calibri" pitchFamily="34" charset="0"/>
+                <a:ea typeface="Calibri" pitchFamily="34" charset="-122"/>
+                <a:cs typeface="Calibri" pitchFamily="34" charset="-120"/>
+              </a:rPr>
+              <a:t>EXPLOITATION</a:t>
+            </a:r>
+            <a:endParaRPr lang="en-US" sz="1200" dirty="0"/>
+          </a:p>
+        </p:txBody>
+      </p:sp>
+      <p:sp>
+        <p:nvSpPr>
+          <p:cNvPr id="3" name="Text 1"/>
+          <p:cNvSpPr/>
+          <p:nvPr/>
+        </p:nvSpPr>
+        <p:spPr>
+          <a:xfrm>
+            <a:off x="548640" y="640080"/>
+            <a:ext cx="11064240" cy="640080"/>
+          </a:xfrm>
+          <a:prstGeom prst="rect">
+            <a:avLst/>
+          </a:prstGeom>
+          <a:noFill/>
+          <a:ln/>
+        </p:spPr>
+        <p:txBody>
+          <a:bodyPr wrap="square" lIns="0" tIns="0" rIns="0" bIns="0" rtlCol="0" anchor="ctr"/>
+          <a:lstStyle/>
+          <a:p>
+            <a:pPr marL="0" indent="0">
+              <a:buNone/>
+            </a:pPr>
+            <a:r>
+              <a:rPr lang="en-US" sz="3000" b="1" dirty="0">
+                <a:solidFill>
+                  <a:srgbClr val="1A1F36"/>
+                </a:solidFill>
+                <a:latin typeface="Georgia" pitchFamily="34" charset="0"/>
+                <a:ea typeface="Georgia" pitchFamily="34" charset="-122"/>
+                <a:cs typeface="Georgia" pitchFamily="34" charset="-120"/>
+              </a:rPr>
+              <a:t>Qualité, données et restitution</a:t>
+            </a:r>
+            <a:endParaRPr lang="en-US" sz="3000" dirty="0"/>
+          </a:p>
+        </p:txBody>
+      </p:sp>
+      <p:sp>
+        <p:nvSpPr>
+          <p:cNvPr id="4" name="Shape 2"/>
+          <p:cNvSpPr/>
+          <p:nvPr/>
+        </p:nvSpPr>
+        <p:spPr>
+          <a:xfrm>
+            <a:off x="548640" y="1508760"/>
+            <a:ext cx="5394960" cy="4064000"/>
+          </a:xfrm>
+          <a:prstGeom prst="rect">
+            <a:avLst/>
+          </a:prstGeom>
+          <a:solidFill>
+            <a:srgbClr val="FFFFFF"/>
+          </a:solidFill>
+          <a:ln w="12700">
+            <a:solidFill>
+              <a:srgbClr val="E3E5F0"/>
+            </a:solidFill>
+            <a:prstDash val="solid"/>
+          </a:ln>
+          <a:effectLst>
+            <a:outerShdw blurRad="114300" dist="38100" dir="8100000" algn="bl" rotWithShape="0">
+              <a:srgbClr val="000000">
+                <a:alpha val="16000"/>
+              </a:srgbClr>
+            </a:outerShdw>
+          </a:effectLst>
+        </p:spPr>
+        <p:txBody>
+          <a:bodyPr/>
+          <a:lstStyle/>
+          <a:p>
+            <a:endParaRPr lang="fr-FR"/>
+          </a:p>
+        </p:txBody>
+      </p:sp>
+      <p:sp>
+        <p:nvSpPr>
+          <p:cNvPr id="5" name="Shape 3"/>
+          <p:cNvSpPr/>
+          <p:nvPr/>
+        </p:nvSpPr>
+        <p:spPr>
+          <a:xfrm>
+            <a:off x="548640" y="1508760"/>
+            <a:ext cx="5394960" cy="868680"/>
+          </a:xfrm>
+          <a:prstGeom prst="rect">
+            <a:avLst/>
+          </a:prstGeom>
+          <a:solidFill>
+            <a:srgbClr val="1D9E75"/>
+          </a:solidFill>
+          <a:ln/>
+        </p:spPr>
+        <p:txBody>
+          <a:bodyPr/>
+          <a:lstStyle/>
+          <a:p>
+            <a:endParaRPr lang="fr-FR"/>
+          </a:p>
+        </p:txBody>
+      </p:sp>
+      <p:pic>
+        <p:nvPicPr>
+          <p:cNvPr id="6" name="Image 0" descr="preencoded.png"/>
+          <p:cNvPicPr>
+            <a:picLocks noChangeAspect="1"/>
+          </p:cNvPicPr>
+          <p:nvPr/>
+        </p:nvPicPr>
+        <p:blipFill>
+          <a:blip r:embed="rId3"/>
+          <a:stretch>
+            <a:fillRect/>
+          </a:stretch>
+        </p:blipFill>
+        <p:spPr>
+          <a:xfrm>
+            <a:off x="868680" y="1691640"/>
+            <a:ext cx="502920" cy="502920"/>
+          </a:xfrm>
+          <a:prstGeom prst="rect">
+            <a:avLst/>
+          </a:prstGeom>
+        </p:spPr>
+      </p:pic>
+      <p:sp>
+        <p:nvSpPr>
+          <p:cNvPr id="7" name="Text 4"/>
+          <p:cNvSpPr/>
+          <p:nvPr/>
+        </p:nvSpPr>
+        <p:spPr>
+          <a:xfrm>
+            <a:off x="1508760" y="1664208"/>
+            <a:ext cx="4297680" cy="320040"/>
+          </a:xfrm>
+          <a:prstGeom prst="rect">
+            <a:avLst/>
+          </a:prstGeom>
+          <a:noFill/>
+          <a:ln/>
+        </p:spPr>
+        <p:txBody>
+          <a:bodyPr wrap="square" lIns="0" tIns="0" rIns="0" bIns="0" rtlCol="0" anchor="ctr"/>
+          <a:lstStyle/>
+          <a:p>
+            <a:pPr marL="0" indent="0">
+              <a:buNone/>
+            </a:pPr>
+            <a:r>
+              <a:rPr lang="en-US" sz="1400" b="1" kern="0" spc="100" dirty="0">
+                <a:solidFill>
+                  <a:srgbClr val="FFFFFF"/>
+                </a:solidFill>
+                <a:latin typeface="Calibri" pitchFamily="34" charset="0"/>
+                <a:ea typeface="Calibri" pitchFamily="34" charset="-122"/>
+                <a:cs typeface="Calibri" pitchFamily="34" charset="-120"/>
+              </a:rPr>
+              <a:t>PREUVES EXÉCUTÉES</a:t>
+            </a:r>
+            <a:endParaRPr lang="en-US" sz="1400" dirty="0"/>
+          </a:p>
+        </p:txBody>
+      </p:sp>
+      <p:sp>
+        <p:nvSpPr>
+          <p:cNvPr id="8" name="Text 5"/>
+          <p:cNvSpPr/>
+          <p:nvPr/>
+        </p:nvSpPr>
+        <p:spPr>
+          <a:xfrm>
+            <a:off x="1508760" y="2006600"/>
+            <a:ext cx="4297680" cy="320040"/>
+          </a:xfrm>
+          <a:prstGeom prst="rect">
+            <a:avLst/>
+          </a:prstGeom>
+          <a:noFill/>
+          <a:ln/>
+        </p:spPr>
+        <p:txBody>
+          <a:bodyPr wrap="square" lIns="0" tIns="0" rIns="0" bIns="0" rtlCol="0" anchor="ctr"/>
+          <a:lstStyle/>
+          <a:p>
+            <a:pPr marL="0" indent="0">
+              <a:buNone/>
+            </a:pPr>
+            <a:r>
+              <a:rPr lang="en-US" sz="1200" dirty="0">
+                <a:solidFill>
+                  <a:srgbClr val="EAF0FA"/>
+                </a:solidFill>
+                <a:latin typeface="Calibri" pitchFamily="34" charset="0"/>
+                <a:ea typeface="Calibri" pitchFamily="34" charset="-122"/>
+                <a:cs typeface="Calibri" pitchFamily="34" charset="-120"/>
+              </a:rPr>
+              <a:t>make test · make queries-check · make tf-validate</a:t>
+            </a:r>
+            <a:endParaRPr lang="en-US" sz="1200" dirty="0"/>
+          </a:p>
+        </p:txBody>
+      </p:sp>
+      <p:sp>
+        <p:nvSpPr>
+          <p:cNvPr id="9" name="Text 6"/>
+          <p:cNvSpPr/>
+          <p:nvPr/>
+        </p:nvSpPr>
+        <p:spPr>
+          <a:xfrm>
+            <a:off x="914400" y="2697480"/>
+            <a:ext cx="4709160" cy="2743200"/>
+          </a:xfrm>
+          <a:prstGeom prst="rect">
+            <a:avLst/>
+          </a:prstGeom>
+          <a:noFill/>
+          <a:ln/>
+        </p:spPr>
+        <p:txBody>
+          <a:bodyPr wrap="square" lIns="0" tIns="0" rIns="0" bIns="0" rtlCol="0" anchor="t"/>
+          <a:lstStyle/>
+          <a:p>
+            <a:pPr marL="342900" indent="-342900">
+              <a:spcAft>
+                <a:spcPts val="4100"/>
+              </a:spcAft>
+              <a:buSzPct val="100000"/>
+              <a:buChar char="•"/>
+            </a:pPr>
+            <a:r>
+              <a:rPr lang="en-US" sz="1500" dirty="0">
+                <a:solidFill>
+                  <a:srgbClr val="1A1F36"/>
+                </a:solidFill>
+                <a:latin typeface="Calibri" pitchFamily="34" charset="0"/>
+                <a:ea typeface="Calibri" pitchFamily="34" charset="-122"/>
+                <a:cs typeface="Calibri" pitchFamily="34" charset="-120"/>
+              </a:rPr>
+              <a:t>16/16 tests de bout en bout au vert</a:t>
+            </a:r>
+            <a:endParaRPr lang="en-US" sz="1500" dirty="0"/>
+          </a:p>
+          <a:p>
+            <a:pPr marL="342900" indent="-342900">
+              <a:spcAft>
+                <a:spcPts val="4100"/>
+              </a:spcAft>
+              <a:buSzPct val="100000"/>
+              <a:buChar char="•"/>
+            </a:pPr>
+            <a:r>
+              <a:rPr lang="en-US" sz="1500" dirty="0">
+                <a:solidFill>
+                  <a:srgbClr val="1A1F36"/>
+                </a:solidFill>
+                <a:latin typeface="Calibri" pitchFamily="34" charset="0"/>
+                <a:ea typeface="Calibri" pitchFamily="34" charset="-122"/>
+                <a:cs typeface="Calibri" pitchFamily="34" charset="-120"/>
+              </a:rPr>
+              <a:t>Requêtes : 9 SQL + 11 MongoDB exécutées</a:t>
+            </a:r>
+            <a:endParaRPr lang="en-US" sz="1500" dirty="0"/>
+          </a:p>
+          <a:p>
+            <a:pPr marL="342900" indent="-342900">
+              <a:spcAft>
+                <a:spcPts val="4100"/>
+              </a:spcAft>
+              <a:buSzPct val="100000"/>
+              <a:buChar char="•"/>
+            </a:pPr>
+            <a:r>
+              <a:rPr lang="en-US" sz="1500" dirty="0">
+                <a:solidFill>
+                  <a:srgbClr val="1A1F36"/>
+                </a:solidFill>
+                <a:latin typeface="Calibri" pitchFamily="34" charset="0"/>
+                <a:ea typeface="Calibri" pitchFamily="34" charset="-122"/>
+                <a:cs typeface="Calibri" pitchFamily="34" charset="-120"/>
+              </a:rPr>
+              <a:t>RGPD : anonymize_customer() · TTL 90 j</a:t>
+            </a:r>
+            <a:endParaRPr lang="en-US" sz="1500" dirty="0"/>
+          </a:p>
+          <a:p>
+            <a:pPr marL="342900" indent="-342900">
+              <a:spcAft>
+                <a:spcPts val="4100"/>
+              </a:spcAft>
+              <a:buSzPct val="100000"/>
+              <a:buChar char="•"/>
+            </a:pPr>
+            <a:r>
+              <a:rPr lang="en-US" sz="1500" dirty="0">
+                <a:solidFill>
+                  <a:srgbClr val="1A1F36"/>
+                </a:solidFill>
+                <a:latin typeface="Calibri" pitchFamily="34" charset="0"/>
+                <a:ea typeface="Calibri" pitchFamily="34" charset="-122"/>
+                <a:cs typeface="Calibri" pitchFamily="34" charset="-120"/>
+              </a:rPr>
+              <a:t>Score + fraud_indicators en 1 transaction</a:t>
+            </a:r>
+            <a:endParaRPr lang="en-US" sz="1500" dirty="0"/>
+          </a:p>
+        </p:txBody>
+      </p:sp>
+      <p:sp>
+        <p:nvSpPr>
+          <p:cNvPr id="10" name="Shape 7"/>
+          <p:cNvSpPr/>
+          <p:nvPr/>
+        </p:nvSpPr>
+        <p:spPr>
+          <a:xfrm>
+            <a:off x="6172200" y="1508760"/>
+            <a:ext cx="5394960" cy="4064000"/>
+          </a:xfrm>
+          <a:prstGeom prst="rect">
+            <a:avLst/>
+          </a:prstGeom>
+          <a:solidFill>
+            <a:srgbClr val="FFFFFF"/>
+          </a:solidFill>
+          <a:ln w="12700">
+            <a:solidFill>
+              <a:srgbClr val="E3E5F0"/>
+            </a:solidFill>
+            <a:prstDash val="solid"/>
+          </a:ln>
+          <a:effectLst>
+            <a:outerShdw blurRad="114300" dist="38100" dir="8100000" algn="bl" rotWithShape="0">
+              <a:srgbClr val="000000">
+                <a:alpha val="16000"/>
+              </a:srgbClr>
+            </a:outerShdw>
+          </a:effectLst>
+        </p:spPr>
+        <p:txBody>
+          <a:bodyPr/>
+          <a:lstStyle/>
+          <a:p>
+            <a:endParaRPr lang="fr-FR"/>
+          </a:p>
+        </p:txBody>
+      </p:sp>
+      <p:sp>
+        <p:nvSpPr>
+          <p:cNvPr id="11" name="Shape 8"/>
+          <p:cNvSpPr/>
+          <p:nvPr/>
+        </p:nvSpPr>
+        <p:spPr>
+          <a:xfrm>
+            <a:off x="6172200" y="1508760"/>
+            <a:ext cx="5394960" cy="868680"/>
+          </a:xfrm>
+          <a:prstGeom prst="rect">
+            <a:avLst/>
+          </a:prstGeom>
+          <a:solidFill>
+            <a:srgbClr val="2F7BD6"/>
+          </a:solidFill>
+          <a:ln/>
+        </p:spPr>
+        <p:txBody>
+          <a:bodyPr/>
+          <a:lstStyle/>
+          <a:p>
+            <a:endParaRPr lang="fr-FR"/>
+          </a:p>
+        </p:txBody>
+      </p:sp>
+      <p:pic>
+        <p:nvPicPr>
+          <p:cNvPr id="12" name="Image 1" descr="preencoded.png"/>
+          <p:cNvPicPr>
+            <a:picLocks noChangeAspect="1"/>
+          </p:cNvPicPr>
+          <p:nvPr/>
+        </p:nvPicPr>
+        <p:blipFill>
+          <a:blip r:embed="rId4"/>
+          <a:stretch>
+            <a:fillRect/>
+          </a:stretch>
+        </p:blipFill>
+        <p:spPr>
+          <a:xfrm>
+            <a:off x="6492240" y="1691640"/>
+            <a:ext cx="502920" cy="502920"/>
+          </a:xfrm>
+          <a:prstGeom prst="rect">
+            <a:avLst/>
+          </a:prstGeom>
+        </p:spPr>
+      </p:pic>
+      <p:sp>
+        <p:nvSpPr>
+          <p:cNvPr id="13" name="Text 9"/>
+          <p:cNvSpPr/>
+          <p:nvPr/>
+        </p:nvSpPr>
+        <p:spPr>
+          <a:xfrm>
+            <a:off x="7132320" y="1664208"/>
+            <a:ext cx="4297680" cy="320040"/>
+          </a:xfrm>
+          <a:prstGeom prst="rect">
+            <a:avLst/>
+          </a:prstGeom>
+          <a:noFill/>
+          <a:ln/>
+        </p:spPr>
+        <p:txBody>
+          <a:bodyPr wrap="square" lIns="0" tIns="0" rIns="0" bIns="0" rtlCol="0" anchor="ctr"/>
+          <a:lstStyle/>
+          <a:p>
+            <a:pPr marL="0" indent="0">
+              <a:buNone/>
+            </a:pPr>
+            <a:r>
+              <a:rPr lang="en-US" sz="1400" b="1" kern="0" spc="100" dirty="0">
+                <a:solidFill>
+                  <a:srgbClr val="FFFFFF"/>
+                </a:solidFill>
+                <a:latin typeface="Calibri" pitchFamily="34" charset="0"/>
+                <a:ea typeface="Calibri" pitchFamily="34" charset="-122"/>
+                <a:cs typeface="Calibri" pitchFamily="34" charset="-120"/>
+              </a:rPr>
+              <a:t>DASHBOARD &amp; MLOPS</a:t>
+            </a:r>
+            <a:endParaRPr lang="en-US" sz="1400" dirty="0"/>
+          </a:p>
+        </p:txBody>
+      </p:sp>
+      <p:sp>
+        <p:nvSpPr>
+          <p:cNvPr id="14" name="Text 10"/>
+          <p:cNvSpPr/>
+          <p:nvPr/>
+        </p:nvSpPr>
+        <p:spPr>
+          <a:xfrm>
+            <a:off x="7132320" y="2006600"/>
+            <a:ext cx="4297680" cy="320040"/>
+          </a:xfrm>
+          <a:prstGeom prst="rect">
+            <a:avLst/>
+          </a:prstGeom>
+          <a:noFill/>
+          <a:ln/>
+        </p:spPr>
+        <p:txBody>
+          <a:bodyPr wrap="square" lIns="0" tIns="0" rIns="0" bIns="0" rtlCol="0" anchor="ctr"/>
+          <a:lstStyle/>
+          <a:p>
+            <a:pPr marL="0" indent="0">
+              <a:buNone/>
+            </a:pPr>
+            <a:r>
+              <a:rPr lang="en-US" sz="1200" dirty="0">
+                <a:solidFill>
+                  <a:srgbClr val="EAF0FA"/>
+                </a:solidFill>
+                <a:latin typeface="Calibri" pitchFamily="34" charset="0"/>
+                <a:ea typeface="Calibri" pitchFamily="34" charset="-122"/>
+                <a:cs typeface="Calibri" pitchFamily="34" charset="-120"/>
+              </a:rPr>
+              <a:t>localhost:8501 · admin / Bloc2-Demo-2026</a:t>
+            </a:r>
+            <a:endParaRPr lang="en-US" sz="1200" dirty="0"/>
+          </a:p>
+        </p:txBody>
+      </p:sp>
+      <p:sp>
+        <p:nvSpPr>
+          <p:cNvPr id="15" name="Text 11"/>
+          <p:cNvSpPr/>
+          <p:nvPr/>
+        </p:nvSpPr>
+        <p:spPr>
+          <a:xfrm>
+            <a:off x="6537960" y="2697480"/>
+            <a:ext cx="4709160" cy="2743200"/>
+          </a:xfrm>
+          <a:prstGeom prst="rect">
+            <a:avLst/>
+          </a:prstGeom>
+          <a:noFill/>
+          <a:ln/>
+        </p:spPr>
+        <p:txBody>
+          <a:bodyPr wrap="square" lIns="0" tIns="0" rIns="0" bIns="0" rtlCol="0" anchor="t"/>
+          <a:lstStyle/>
+          <a:p>
+            <a:pPr marL="342900" indent="-342900">
+              <a:spcAft>
+                <a:spcPts val="4100"/>
+              </a:spcAft>
+              <a:buSzPct val="100000"/>
+              <a:buChar char="•"/>
+            </a:pPr>
+            <a:r>
+              <a:rPr lang="en-US" sz="1500" dirty="0">
+                <a:solidFill>
+                  <a:srgbClr val="1A1F36"/>
+                </a:solidFill>
+                <a:latin typeface="Calibri" pitchFamily="34" charset="0"/>
+                <a:ea typeface="Calibri" pitchFamily="34" charset="-122"/>
+                <a:cs typeface="Calibri" pitchFamily="34" charset="-120"/>
+              </a:rPr>
+              <a:t>Vue d’ensemble : KPIs, alertes, suspects</a:t>
+            </a:r>
+            <a:endParaRPr lang="en-US" sz="1500" dirty="0"/>
+          </a:p>
+          <a:p>
+            <a:pPr marL="342900" indent="-342900">
+              <a:spcAft>
+                <a:spcPts val="4100"/>
+              </a:spcAft>
+              <a:buSzPct val="100000"/>
+              <a:buChar char="•"/>
+            </a:pPr>
+            <a:r>
+              <a:rPr lang="en-US" sz="1500" dirty="0">
+                <a:solidFill>
+                  <a:srgbClr val="1A1F36"/>
+                </a:solidFill>
+                <a:latin typeface="Calibri" pitchFamily="34" charset="0"/>
+                <a:ea typeface="Calibri" pitchFamily="34" charset="-122"/>
+                <a:cs typeface="Calibri" pitchFamily="34" charset="-120"/>
+              </a:rPr>
+              <a:t>Performance ML : dérive, précision servie</a:t>
+            </a:r>
+            <a:endParaRPr lang="en-US" sz="1500" dirty="0"/>
+          </a:p>
+          <a:p>
+            <a:pPr marL="342900" indent="-342900">
+              <a:spcAft>
+                <a:spcPts val="4100"/>
+              </a:spcAft>
+              <a:buSzPct val="100000"/>
+              <a:buChar char="•"/>
+            </a:pPr>
+            <a:r>
+              <a:rPr lang="en-US" sz="1500" dirty="0">
+                <a:solidFill>
+                  <a:srgbClr val="1A1F36"/>
+                </a:solidFill>
+                <a:latin typeface="Calibri" pitchFamily="34" charset="0"/>
+                <a:ea typeface="Calibri" pitchFamily="34" charset="-122"/>
+                <a:cs typeface="Calibri" pitchFamily="34" charset="-120"/>
+              </a:rPr>
+              <a:t>MLflow · Evidently · retrain automatique</a:t>
+            </a:r>
+            <a:endParaRPr lang="en-US" sz="1500" dirty="0"/>
+          </a:p>
+          <a:p>
+            <a:pPr marL="342900" indent="-342900">
+              <a:spcAft>
+                <a:spcPts val="4100"/>
+              </a:spcAft>
+              <a:buSzPct val="100000"/>
+              <a:buChar char="•"/>
+            </a:pPr>
+            <a:r>
+              <a:rPr lang="en-US" sz="1500" dirty="0">
+                <a:solidFill>
+                  <a:srgbClr val="1A1F36"/>
+                </a:solidFill>
+                <a:latin typeface="Calibri" pitchFamily="34" charset="0"/>
+                <a:ea typeface="Calibri" pitchFamily="34" charset="-122"/>
+                <a:cs typeface="Calibri" pitchFamily="34" charset="-120"/>
+              </a:rPr>
+              <a:t>Diagrammes régénérés depuis le code</a:t>
+            </a:r>
+            <a:endParaRPr lang="en-US" sz="1500" dirty="0"/>
+          </a:p>
+        </p:txBody>
+      </p:sp>
+      <p:sp>
+        <p:nvSpPr>
+          <p:cNvPr id="16" name="Text 12"/>
+          <p:cNvSpPr/>
+          <p:nvPr/>
+        </p:nvSpPr>
+        <p:spPr>
+          <a:xfrm>
+            <a:off x="548640" y="5740400"/>
+            <a:ext cx="11064240" cy="365760"/>
+          </a:xfrm>
+          <a:prstGeom prst="rect">
+            <a:avLst/>
+          </a:prstGeom>
+          <a:noFill/>
+          <a:ln/>
+        </p:spPr>
+        <p:txBody>
+          <a:bodyPr wrap="square" lIns="0" tIns="0" rIns="0" bIns="0" rtlCol="0" anchor="ctr"/>
+          <a:lstStyle/>
+          <a:p>
+            <a:pPr marL="0" indent="0" algn="ctr">
+              <a:buNone/>
+            </a:pPr>
+            <a:r>
+              <a:rPr lang="en-US" sz="1300" i="1" dirty="0">
+                <a:solidFill>
+                  <a:srgbClr val="6B7280"/>
+                </a:solidFill>
+                <a:latin typeface="Calibri" pitchFamily="34" charset="0"/>
+                <a:ea typeface="Calibri" pitchFamily="34" charset="-122"/>
+                <a:cs typeface="Calibri" pitchFamily="34" charset="-120"/>
+              </a:rPr>
+              <a:t>Chaque affirmation se vérifie par une commande du Makefile ou un onglet du dashboard.</a:t>
+            </a:r>
+            <a:endParaRPr lang="en-US" sz="1300" dirty="0"/>
+          </a:p>
+        </p:txBody>
+      </p:sp>
+      <p:sp>
+        <p:nvSpPr>
+          <p:cNvPr id="17" name="Text 13"/>
+          <p:cNvSpPr/>
+          <p:nvPr/>
+        </p:nvSpPr>
+        <p:spPr>
+          <a:xfrm>
+            <a:off x="11430000" y="6355080"/>
+            <a:ext cx="548640" cy="274320"/>
+          </a:xfrm>
+          <a:prstGeom prst="rect">
+            <a:avLst/>
+          </a:prstGeom>
+          <a:noFill/>
+          <a:ln/>
+        </p:spPr>
+        <p:txBody>
+          <a:bodyPr wrap="square" lIns="0" tIns="0" rIns="0" bIns="0" rtlCol="0" anchor="ctr"/>
+          <a:lstStyle/>
+          <a:p>
+            <a:pPr marL="0" indent="0" algn="r">
+              <a:buNone/>
+            </a:pPr>
+            <a:r>
+              <a:rPr lang="en-US" sz="1100" dirty="0">
+                <a:solidFill>
+                  <a:srgbClr val="6B7280"/>
+                </a:solidFill>
+                <a:latin typeface="Calibri" pitchFamily="34" charset="0"/>
+                <a:ea typeface="Calibri" pitchFamily="34" charset="-122"/>
+                <a:cs typeface="Calibri" pitchFamily="34" charset="-120"/>
+              </a:rPr>
+              <a:t>10</a:t>
+            </a:r>
+            <a:endParaRPr lang="en-US" sz="1100" dirty="0"/>
+          </a:p>
+        </p:txBody>
+      </p:sp>
+    </p:spTree>
+    <p:extLst>
+      <p:ext uri="{BB962C8B-B14F-4D97-AF65-F5344CB8AC3E}">
+        <p14:creationId xmlns:p14="http://schemas.microsoft.com/office/powerpoint/2010/main" val="3302546916"/>
+      </p:ext>
+    </p:extLst>
   </p:cSld>
   <p:clrMapOvr>
     <a:masterClrMapping/>

</xml_diff>

<commit_message>
Harmonise le français de la documentation et des livrables
- Anglicismes évitables remplacés dans la prose (repli, rafales, instantané,
  consommateur, dérive, rappel, suivi, rechargement à chaud, délai de carence…) ;
  code, commandes, noms de champs et titres inchangés
- Diagrammes régénérés, images mises à jour dans la présentation et les
  deux documents Word ; « drift » conservé quand il désigne un champ MongoDB
</commit_message>
<xml_diff>
--- a/presentation/stripe_presentation_bloc2.pptx
+++ b/presentation/stripe_presentation_bloc2.pptx
@@ -17,12 +17,12 @@
     <p:sldId id="267" r:id="rId8"/>
     <p:sldId id="273" r:id="rId9"/>
     <p:sldId id="262" r:id="rId10"/>
-    <p:sldId id="274" r:id="rId19"/>
     <p:sldId id="263" r:id="rId11"/>
     <p:sldId id="271" r:id="rId12"/>
     <p:sldId id="277" r:id="rId22"/>
+    <p:sldId id="265" r:id="rId13"/>
+    <p:sldId id="274" r:id="rId19"/>
     <p:sldId id="276" r:id="rId21"/>
-    <p:sldId id="265" r:id="rId13"/>
     <p:sldId id="275" r:id="rId20"/>
   </p:sldIdLst>
   <p:sldSz cx="12192000" cy="6858000"/>
@@ -2237,7 +2237,7 @@
                 <a:ea typeface="Calibri" pitchFamily="34" charset="-122"/>
                 <a:cs typeface="Calibri" pitchFamily="34" charset="-120"/>
               </a:rPr>
-              <a:t>XGBoost (MLflow) ou 5 règles en fallback ; seuils 0.60 / 0.85</a:t>
+              <a:t>XGBoost (MLflow) ou 5 règles en repli ; seuils 0.60 / 0.85</a:t>
             </a:r>
             <a:endParaRPr lang="en-US" sz="1500" dirty="0"/>
           </a:p>
@@ -4577,7 +4577,7 @@
                 <a:ea typeface="Calibri" pitchFamily="34" charset="-122"/>
                 <a:cs typeface="Calibri" pitchFamily="34" charset="-120"/>
               </a:rPr>
-              <a:t>MLflow · Evidently · retrain automatique</a:t>
+              <a:t>MLflow · Evidently · réentraînement automatique</a:t>
             </a:r>
             <a:endParaRPr lang="en-US" sz="1500" dirty="0"/>
           </a:p>
@@ -10440,7 +10440,7 @@
                 <a:ea typeface="Calibri" pitchFamily="34" charset="-122"/>
                 <a:cs typeface="Calibri" pitchFamily="34" charset="-120"/>
               </a:rPr>
-              <a:t>Snapshot de features par client (upsert sur customer_id). ml_monitoring : dérive et précision servie (Evidently).</a:t>
+              <a:t>Instantané de features par client (upsert sur customer_id). ml_monitoring : dérive et précision servie (Evidently).</a:t>
             </a:r>
             <a:endParaRPr lang="en-US" sz="1400" dirty="0"/>
           </a:p>

</xml_diff>

<commit_message>
Applique les neuf constats de la revue qualité et cohérence
- CI e2e : démarre mongo_writer et rend le test fraud_alerts strict
  (E2E_STRICT=1) : la couche NoSQL est réellement exercée
- init/mongo/01_init_collections.js idempotent + make mongo-indexes, appelé
  par make seed : les nouveaux index arrivent sur les volumes existants
- Un seul nom de variable pour les seuils (FRAUD_SCORE_THRESHOLD,
  REVIEW_SCORE_THRESHOLD) dans les tests, le job PyFlink et le notebook
- Slides 3 et 5 : le scoring Python remplace Flink dans le pipeline réel
- Plan sécurité : le superutilisateur stripe_app entre dans les écarts assumés
- demo.sh réutilise .venv (make install) et MONGO_WRITER_PYTHON
- Script vidéo : profil airflow pour cohérence avec les neuf conteneurs
- Commentaire obsolète de mongo_writer.py corrigé
</commit_message>
<xml_diff>
--- a/presentation/stripe_presentation_bloc2.pptx
+++ b/presentation/stripe_presentation_bloc2.pptx
@@ -6274,7 +6274,7 @@
                 <a:ea typeface="Georgia" pitchFamily="34" charset="-122"/>
                 <a:cs typeface="Georgia" pitchFamily="34" charset="-120"/>
               </a:rPr>
-              <a:t>Kafka + Flink</a:t>
+              <a:t>Kafka + scoring Python</a:t>
             </a:r>
             <a:endParaRPr lang="en-US" sz="2300" dirty="0"/>
           </a:p>
@@ -7435,7 +7435,7 @@
                 <a:ea typeface="Calibri" pitchFamily="34" charset="-122"/>
                 <a:cs typeface="Calibri" pitchFamily="34" charset="-120"/>
               </a:rPr>
-              <a:t>Flink + Redis</a:t>
+              <a:t>Scorer + Redis</a:t>
             </a:r>
             <a:endParaRPr lang="en-US" sz="1400" dirty="0"/>
           </a:p>

</xml_diff>